<commit_message>
Modificar peticiones de cliente
</commit_message>
<xml_diff>
--- a/chapter_sync/outputs/2025-07-02_Presentation.pptx
+++ b/chapter_sync/outputs/2025-07-02_Presentation.pptx
@@ -13858,8 +13858,32 @@
         </p:blipFill>
         <p:spPr>
           <a:xfrm>
-            <a:off x="1828800" y="911265"/>
-            <a:ext cx="8534400" cy="5035469"/>
+            <a:off x="3333750" y="182880"/>
+            <a:ext cx="5524500" cy="3259567"/>
+          </a:xfrm>
+          <a:prstGeom prst="rect">
+            <a:avLst/>
+          </a:prstGeom>
+        </p:spPr>
+      </p:pic>
+      <p:pic>
+        <p:nvPicPr>
+          <p:cNvPr id="118" name="Picture 117" descr="image.png"/>
+          <p:cNvPicPr>
+            <a:picLocks noChangeAspect="1"/>
+          </p:cNvPicPr>
+          <p:nvPr/>
+        </p:nvPicPr>
+        <p:blipFill>
+          <a:blip r:embed="rId4"/>
+          <a:stretch>
+            <a:fillRect/>
+          </a:stretch>
+        </p:blipFill>
+        <p:spPr>
+          <a:xfrm>
+            <a:off x="3333750" y="3488167"/>
+            <a:ext cx="5524500" cy="3250799"/>
           </a:xfrm>
           <a:prstGeom prst="rect">
             <a:avLst/>

</xml_diff>